<commit_message>
feat: add live evaluation demo suite, edge benchmarking, and review presentation materials
- Add demo_live.py with unified YOLOv10n obstacle detection and high-recall pothole avoidance
- Add dedicated demo_pothole_live.py and demo_yolov10_live.py standalone evaluation scripts
- Add benchmark.py multi-runtime edge benchmarking suite (PyTorch, NCNN, ONNX, OpenVINO)
- Update capstone presentation (.pptx) with real training curves, perception HUDs, and YOLOv10n telemetry
- Reorganize presentation generator tools into tools/presentation/
- Add slide screenshots to docs/reports/screenshots/ and update .gitignore
</commit_message>
<xml_diff>
--- a/docs/reports/capstone_presentation_base.pptx
+++ b/docs/reports/capstone_presentation_base.pptx
@@ -8373,7 +8373,7 @@
                 </a:solidFill>
                 <a:latin typeface="Segoe UI"/>
               </a:rPr>
-              <a:t>python test_yolov10_video.py --video dashcam_test.mp4</a:t>
+              <a:t>python test_yolov10_video.py --video pothole_test_2.mp4</a:t>
             </a:r>
           </a:p>
           <a:p>
@@ -9084,7 +9084,7 @@
                 </a:solidFill>
                 <a:latin typeface="Segoe UI"/>
               </a:rPr>
-              <a:t>Run RDD2022 YOLOv8n + CV fallback in the live loop</a:t>
+              <a:t>Run RDD2022 YOLOv10n + CV fallback in the live loop</a:t>
             </a:r>
           </a:p>
           <a:p>
@@ -11103,7 +11103,7 @@
                 </a:solidFill>
                 <a:latin typeface="Segoe UI"/>
               </a:rPr>
-              <a:t>• Pothole engine (RDD2022 YOLOv8n + CV)</a:t>
+              <a:t>• Pothole engine (RDD2022 YOLOv10n + CV)</a:t>
             </a:r>
           </a:p>
           <a:p>
@@ -14233,7 +14233,7 @@
                 </a:solidFill>
                 <a:latin typeface="Segoe UI"/>
               </a:rPr>
-              <a:t>RDD2022 YOLOv8n + CV</a:t>
+              <a:t>RDD2022 YOLOv10n + CV</a:t>
             </a:r>
           </a:p>
         </p:txBody>
@@ -15892,7 +15892,7 @@
                 </a:solidFill>
                 <a:latin typeface="Segoe UI"/>
               </a:rPr>
-              <a:t>YOLOv8n fine-tuned on RDD2022 (India subset, pothole class)</a:t>
+              <a:t>Custom YOLOv10n fine-tuned on RDD2022 (India subset, D40 pothole class)</a:t>
             </a:r>
           </a:p>
           <a:p>
@@ -15917,7 +15917,7 @@
                 </a:solidFill>
                 <a:latin typeface="Segoe UI"/>
               </a:rPr>
-              <a:t>50 training epochs  •  weights: rdd2022_yolov8n.pt</a:t>
+              <a:t>50 training epochs  •  weights: best.pt (YOLOv10n)</a:t>
             </a:r>
           </a:p>
           <a:p>

</xml_diff>